<commit_message>
Add A8: pure AQC (no Hadamard test, no shadow) appendix backup slide
R060 (pure AQC is safe for its textbook use case; the phase trap is interferometric-only)
was only a one-line footnote on the trap slide -- too little presence for a result a judge
asked about directly. Added as a full backup slide, A8, matching the existing A1-A7
pattern (never presented; jumped to only if asked): the algebraic argument, the same-W
verification table (n=3/5/7, chi err vs worst observable err), and the explicit
phase-perturbation check, all in one self-contained page.

Appendix divider and appendix-map references updated everywhere (trackb.tex, TRACKB_SCRIPT.md,
slides_content.md) from A1-A7 to A1-A8; delivery pack and stale page/slide counts (32->35)
refreshed to match.

Co-Authored-By: Claude Sonnet 5 <noreply@anthropic.com>
</commit_message>
<xml_diff>
--- a/delivery/slides/Team_8.pptx
+++ b/delivery/slides/Team_8.pptx
@@ -39,6 +39,7 @@
     <p:sldId id="287" r:id="rId38"/>
     <p:sldId id="288" r:id="rId39"/>
     <p:sldId id="289" r:id="rId40"/>
+    <p:sldId id="290" r:id="rId41"/>
   </p:sldIdLst>
   <p:sldSz cx="5760720" cy="3243072" type="screen4x3"/>
   <p:notesSz cx="6858000" cy="9144000"/>
@@ -4258,6 +4259,48 @@
       <p:pic>
         <p:nvPicPr>
           <p:cNvPr id="2" name="Picture 1" descr="p-34.png"/>
+          <p:cNvPicPr>
+            <a:picLocks noChangeAspect="1"/>
+          </p:cNvPicPr>
+          <p:nvPr/>
+        </p:nvPicPr>
+        <p:blipFill>
+          <a:blip r:embed="rId2"/>
+          <a:stretch>
+            <a:fillRect/>
+          </a:stretch>
+        </p:blipFill>
+        <p:spPr>
+          <a:xfrm>
+            <a:off x="0" y="0"/>
+            <a:ext cx="5760720" cy="3243072"/>
+          </a:xfrm>
+          <a:prstGeom prst="rect">
+            <a:avLst/>
+          </a:prstGeom>
+        </p:spPr>
+      </p:pic>
+    </p:spTree>
+  </p:cSld>
+  <p:clrMapOvr>
+    <a:masterClrMapping/>
+  </p:clrMapOvr>
+</p:sld>
+</file>
+
+<file path=ppt/slides/slide35.xml><?xml version="1.0" encoding="utf-8"?>
+<p:sld xmlns:a="http://schemas.openxmlformats.org/drawingml/2006/main" xmlns:p="http://schemas.openxmlformats.org/presentationml/2006/main" xmlns:r="http://schemas.openxmlformats.org/officeDocument/2006/relationships">
+  <p:cSld>
+    <p:spTree>
+      <p:nvGrpSpPr>
+        <p:cNvPr id="1" name=""/>
+        <p:cNvGrpSpPr/>
+        <p:nvPr/>
+      </p:nvGrpSpPr>
+      <p:grpSpPr/>
+      <p:pic>
+        <p:nvPicPr>
+          <p:cNvPr id="2" name="Picture 1" descr="p-35.png"/>
           <p:cNvPicPr>
             <a:picLocks noChangeAspect="1"/>
           </p:cNvPicPr>

</xml_diff>